<commit_message>
part 1 report for Newton
</commit_message>
<xml_diff>
--- a/BioPilot/03_deliverables/Part1_Gait_Model_Migration.pptx
+++ b/BioPilot/03_deliverables/Part1_Gait_Model_Migration.pptx
@@ -2948,7 +2948,30 @@
                 <a:ea typeface="Calibri" pitchFamily="34" charset="-122"/>
                 <a:cs typeface="Calibri" pitchFamily="34" charset="-120"/>
               </a:rPr>
-              <a:t>A depth camera records a person doing simple movements (walking, standing, sit-to-stand) as a moving 3-D stick figure.</a:t>
+              <a:t>A depth camera records a person doing simple movements (walking, standing, sit-to-stand)</a:t>
+            </a:r>
+          </a:p>
+          <a:p>
+            <a:pPr marL="203200" indent="-203200">
+              <a:lnSpc>
+                <a:spcPts val="2200"/>
+              </a:lnSpc>
+              <a:spcAft>
+                <a:spcPts val="1200"/>
+              </a:spcAft>
+              <a:buSzPct val="100000"/>
+              <a:buChar char="•"/>
+            </a:pPr>
+            <a:r>
+              <a:rPr lang="en-US" sz="1500" dirty="0">
+                <a:solidFill>
+                  <a:srgbClr val="122A3A"/>
+                </a:solidFill>
+                <a:latin typeface="Calibri" pitchFamily="34" charset="0"/>
+                <a:ea typeface="Calibri" pitchFamily="34" charset="-122"/>
+                <a:cs typeface="Calibri" pitchFamily="34" charset="-120"/>
+              </a:rPr>
+              <a:t>Pre-processing video into a moving 3-D stick figure.</a:t>
             </a:r>
             <a:endParaRPr lang="en-US" sz="1500" dirty="0"/>
           </a:p>

</xml_diff>